<commit_message>
Add official G. Nikhil PBL Internship Report .docx and updated presentation with BeeSkilled certificate
</commit_message>
<xml_diff>
--- a/GCET_Workforce_Analytics_Presentation.pptx
+++ b/GCET_Workforce_Analytics_Presentation.pptx
@@ -3346,14 +3346,14 @@
           <a:lstStyle/>
           <a:p>
             <a:pPr>
-              <a:defRPr sz="1500" b="1">
+              <a:defRPr sz="1600" b="1">
                 <a:solidFill>
                   <a:srgbClr val="1E3A8A"/>
                 </a:solidFill>
               </a:defRPr>
             </a:pPr>
             <a:r>
-              <a:t>G. Shiva Shankar Vara Prasad  /  Nikhil (Nikhil8-coder)</a:t>
+              <a:t>G. Nikhil  (Nikhil G)</a:t>
             </a:r>
           </a:p>
           <a:p>
@@ -3380,7 +3380,7 @@
               </a:defRPr>
             </a:pPr>
             <a:r>
-              <a:t>Unlox Job Bridge Initiative • First Contact in Machine Learning</a:t>
+              <a:t>BeeSkilled Online Internship in Python  •  Tech &amp; Internships Initiative</a:t>
             </a:r>
             <a:br/>
             <a:r>
@@ -6866,18 +6866,18 @@
         </p:nvSpPr>
         <p:spPr>
           <a:xfrm>
-            <a:off x="7863840" y="1371600"/>
-            <a:ext cx="3566160" cy="2286000"/>
+            <a:off x="7589520" y="1371600"/>
+            <a:ext cx="3931920" cy="4846320"/>
           </a:xfrm>
           <a:prstGeom prst="roundRect">
             <a:avLst/>
           </a:prstGeom>
           <a:solidFill>
-            <a:srgbClr val="EEF2FF"/>
+            <a:srgbClr val="FFFFFF"/>
           </a:solidFill>
           <a:ln w="15240">
             <a:solidFill>
-              <a:srgbClr val="E2E8F0"/>
+              <a:srgbClr val="4338CA"/>
             </a:solidFill>
           </a:ln>
         </p:spPr>
@@ -6903,16 +6903,40 @@
           </a:p>
         </p:txBody>
       </p:sp>
-      <p:sp>
-        <p:nvSpPr>
-          <p:cNvPr id="7" name="TextBox 6"/>
+      <p:pic>
+        <p:nvPicPr>
+          <p:cNvPr id="7" name="Picture 6" descr="certificate_beeskilled.png"/>
+          <p:cNvPicPr>
+            <a:picLocks noChangeAspect="1"/>
+          </p:cNvPicPr>
+          <p:nvPr/>
+        </p:nvPicPr>
+        <p:blipFill>
+          <a:blip r:embed="rId2"/>
+          <a:stretch>
+            <a:fillRect/>
+          </a:stretch>
+        </p:blipFill>
+        <p:spPr>
+          <a:xfrm>
+            <a:off x="7635240" y="1737360"/>
+            <a:ext cx="3840480" cy="2713939"/>
+          </a:xfrm>
+          <a:prstGeom prst="rect">
+            <a:avLst/>
+          </a:prstGeom>
+        </p:spPr>
+      </p:pic>
+      <p:sp>
+        <p:nvSpPr>
+          <p:cNvPr id="8" name="TextBox 7"/>
           <p:cNvSpPr txBox="1"/>
           <p:nvPr/>
         </p:nvSpPr>
         <p:spPr>
           <a:xfrm>
-            <a:off x="8046720" y="1554480"/>
-            <a:ext cx="3200400" cy="1920240"/>
+            <a:off x="7635240" y="1417320"/>
+            <a:ext cx="3840480" cy="320040"/>
           </a:xfrm>
           <a:prstGeom prst="rect">
             <a:avLst/>
@@ -6925,129 +6949,15 @@
           </a:bodyPr>
           <a:lstStyle/>
           <a:p>
-            <a:pPr>
-              <a:defRPr sz="1300" b="1">
+            <a:pPr algn="ctr">
+              <a:defRPr sz="1100" b="1">
                 <a:solidFill>
                   <a:srgbClr val="4338CA"/>
                 </a:solidFill>
               </a:defRPr>
             </a:pPr>
             <a:r>
-              <a:t>Certificate</a:t>
-            </a:r>
-          </a:p>
-          <a:p>
-            <a:pPr>
-              <a:spcBef>
-                <a:spcPts val="600"/>
-              </a:spcBef>
-              <a:defRPr sz="1200" b="1">
-                <a:solidFill>
-                  <a:srgbClr val="1E3A8A"/>
-                </a:solidFill>
-              </a:defRPr>
-            </a:pPr>
-            <a:r>
-              <a:t>Unlox Edge Certification</a:t>
-            </a:r>
-            <a:br/>
-            <a:r>
-              <a:t>'First Contact in Machine Learning'</a:t>
-            </a:r>
-          </a:p>
-        </p:txBody>
-      </p:sp>
-      <p:sp>
-        <p:nvSpPr>
-          <p:cNvPr id="8" name="Rounded Rectangle 7"/>
-          <p:cNvSpPr/>
-          <p:nvPr/>
-        </p:nvSpPr>
-        <p:spPr>
-          <a:xfrm>
-            <a:off x="7863840" y="3931920"/>
-            <a:ext cx="3566160" cy="2286000"/>
-          </a:xfrm>
-          <a:prstGeom prst="roundRect">
-            <a:avLst/>
-          </a:prstGeom>
-          <a:solidFill>
-            <a:srgbClr val="EEF2FF"/>
-          </a:solidFill>
-          <a:ln w="15240">
-            <a:solidFill>
-              <a:srgbClr val="E2E8F0"/>
-            </a:solidFill>
-          </a:ln>
-        </p:spPr>
-        <p:style>
-          <a:lnRef idx="1">
-            <a:schemeClr val="accent1"/>
-          </a:lnRef>
-          <a:fillRef idx="3">
-            <a:schemeClr val="accent1"/>
-          </a:fillRef>
-          <a:effectRef idx="2">
-            <a:schemeClr val="accent1"/>
-          </a:effectRef>
-          <a:fontRef idx="minor">
-            <a:schemeClr val="lt1"/>
-          </a:fontRef>
-        </p:style>
-        <p:txBody>
-          <a:bodyPr rtlCol="0" anchor="ctr"/>
-          <a:lstStyle/>
-          <a:p>
-            <a:pPr algn="ctr"/>
-          </a:p>
-        </p:txBody>
-      </p:sp>
-      <p:sp>
-        <p:nvSpPr>
-          <p:cNvPr id="9" name="TextBox 8"/>
-          <p:cNvSpPr txBox="1"/>
-          <p:nvPr/>
-        </p:nvSpPr>
-        <p:spPr>
-          <a:xfrm>
-            <a:off x="8046720" y="4114800"/>
-            <a:ext cx="3200400" cy="1920240"/>
-          </a:xfrm>
-          <a:prstGeom prst="rect">
-            <a:avLst/>
-          </a:prstGeom>
-          <a:noFill/>
-        </p:spPr>
-        <p:txBody>
-          <a:bodyPr wrap="none">
-            <a:spAutoFit/>
-          </a:bodyPr>
-          <a:lstStyle/>
-          <a:p>
-            <a:pPr>
-              <a:defRPr sz="1300" b="1">
-                <a:solidFill>
-                  <a:srgbClr val="4338CA"/>
-                </a:solidFill>
-              </a:defRPr>
-            </a:pPr>
-            <a:r>
-              <a:t>Project</a:t>
-            </a:r>
-          </a:p>
-          <a:p>
-            <a:pPr>
-              <a:spcBef>
-                <a:spcPts val="600"/>
-              </a:spcBef>
-              <a:defRPr sz="1200" b="1">
-                <a:solidFill>
-                  <a:srgbClr val="1E3A8A"/>
-                </a:solidFill>
-              </a:defRPr>
-            </a:pPr>
-            <a:r>
-              <a:t>Enterprise Workforce Intelligence &amp; Analytics Platform</a:t>
+              <a:t>BeeSkilled Verified Internship Certificate</a:t>
             </a:r>
           </a:p>
         </p:txBody>
@@ -7241,7 +7151,7 @@
               </a:defRPr>
             </a:pPr>
             <a:r>
-              <a:t>•  Unlox Academy — Internship &amp; Project-Based Learning Program materials.</a:t>
+              <a:t>•  BeeSkilled — Python Online Internship Program (Tech and Internships) curriculum.</a:t>
             </a:r>
           </a:p>
           <a:p>
@@ -7256,7 +7166,7 @@
               </a:defRPr>
             </a:pPr>
             <a:r>
-              <a:t>•  Unlox Edge Certification — 'First Contact in Machine Learning'.</a:t>
+              <a:t>•  BeeSkilled Certificate of Completion — Awarded to Nikhil G, Issued 07 October 2026.</a:t>
             </a:r>
           </a:p>
           <a:p>
@@ -7979,7 +7889,7 @@
               </a:defRPr>
             </a:pPr>
             <a:r>
-              <a:t>Machine Learning Internship • Unlox Academy</a:t>
+              <a:t>Python Internship • BeeSkilled (Tech &amp; Internships)</a:t>
             </a:r>
           </a:p>
           <a:p>
@@ -8006,7 +7916,7 @@
               </a:defRPr>
             </a:pPr>
             <a:r>
-              <a:t>G. Shiva Shankar Vara Prasad  /  Nikhil (Nikhil8-coder)</a:t>
+              <a:t>G. Nikhil (Nikhil G)</a:t>
             </a:r>
             <a:br/>
             <a:r>

</xml_diff>